<commit_message>
Polish presentation and add submission links
</commit_message>
<xml_diff>
--- a/docs/solution_presentation.pptx
+++ b/docs/solution_presentation.pptx
@@ -15,6 +15,8 @@
     <p:sldId id="263" r:id="rId14"/>
     <p:sldId id="264" r:id="rId15"/>
     <p:sldId id="265" r:id="rId16"/>
+    <p:sldId id="266" r:id="rId17"/>
+    <p:sldId id="267" r:id="rId18"/>
   </p:sldIdLst>
   <p:sldSz cx="12191695" cy="6858000" type="screen4x3"/>
   <p:notesSz cx="6858000" cy="9144000"/>
@@ -3493,7 +3495,7 @@
                 </a:solidFill>
                 <a:latin typeface="Aptos"/>
               </a:rPr>
-              <a:t>TRANSPARENT ENGINEERING</a:t>
+              <a:t>WHAT CHANGES BEYOND EVALUATION</a:t>
             </a:r>
           </a:p>
         </p:txBody>
@@ -3528,7 +3530,7 @@
                 </a:solidFill>
                 <a:latin typeface="Aptos"/>
               </a:rPr>
-              <a:t>AI usage and submission deliverables</a:t>
+              <a:t>Limitations and production plan</a:t>
             </a:r>
           </a:p>
         </p:txBody>
@@ -3613,14 +3615,49 @@
       </p:sp>
       <p:sp>
         <p:nvSpPr>
-          <p:cNvPr id="6" name="Rounded Rectangle 5"/>
+          <p:cNvPr id="6" name="TextBox 5"/>
+          <p:cNvSpPr txBox="1"/>
+          <p:nvPr/>
+        </p:nvSpPr>
+        <p:spPr>
+          <a:xfrm>
+            <a:off x="640080" y="1572768"/>
+            <a:ext cx="10332720" cy="320040"/>
+          </a:xfrm>
+          <a:prstGeom prst="rect">
+            <a:avLst/>
+          </a:prstGeom>
+          <a:noFill/>
+        </p:spPr>
+        <p:txBody>
+          <a:bodyPr wrap="square" lIns="36576" rIns="36576" tIns="36576" bIns="36576" anchor="t">
+            <a:spAutoFit/>
+          </a:bodyPr>
+          <a:lstStyle/>
+          <a:p>
+            <a:pPr algn="l"/>
+            <a:r>
+              <a:rPr sz="1600" b="0">
+                <a:solidFill>
+                  <a:srgbClr val="66767A"/>
+                </a:solidFill>
+                <a:latin typeface="Aptos"/>
+              </a:rPr>
+              <a:t>The evaluation deployment is intentionally small; the seams for production hardening are explicit.</a:t>
+            </a:r>
+          </a:p>
+        </p:txBody>
+      </p:sp>
+      <p:sp>
+        <p:nvSpPr>
+          <p:cNvPr id="7" name="Rounded Rectangle 6"/>
           <p:cNvSpPr/>
           <p:nvPr/>
         </p:nvSpPr>
         <p:spPr>
           <a:xfrm>
-            <a:off x="640080" y="1691640"/>
-            <a:ext cx="5166360" cy="2971800"/>
+            <a:off x="640080" y="2148840"/>
+            <a:ext cx="5166360" cy="2423160"/>
           </a:xfrm>
           <a:prstGeom prst="roundRect">
             <a:avLst/>
@@ -3658,20 +3695,20 @@
       </p:sp>
       <p:sp>
         <p:nvSpPr>
-          <p:cNvPr id="7" name="Rectangle 6"/>
+          <p:cNvPr id="8" name="Rectangle 7"/>
           <p:cNvSpPr/>
           <p:nvPr/>
         </p:nvSpPr>
         <p:spPr>
           <a:xfrm>
-            <a:off x="640080" y="1691640"/>
-            <a:ext cx="54864" cy="2971800"/>
+            <a:off x="640080" y="2148840"/>
+            <a:ext cx="54864" cy="2423160"/>
           </a:xfrm>
           <a:prstGeom prst="rect">
             <a:avLst/>
           </a:prstGeom>
           <a:solidFill>
-            <a:srgbClr val="0F766E"/>
+            <a:srgbClr val="A84232"/>
           </a:solidFill>
           <a:ln>
             <a:noFill/>
@@ -3701,13 +3738,13 @@
       </p:sp>
       <p:sp>
         <p:nvSpPr>
-          <p:cNvPr id="8" name="TextBox 7"/>
-          <p:cNvSpPr txBox="1"/>
-          <p:nvPr/>
-        </p:nvSpPr>
-        <p:spPr>
-          <a:xfrm>
-            <a:off x="822959" y="1856232"/>
+          <p:cNvPr id="9" name="TextBox 8"/>
+          <p:cNvSpPr txBox="1"/>
+          <p:nvPr/>
+        </p:nvSpPr>
+        <p:spPr>
+          <a:xfrm>
+            <a:off x="822959" y="2313432"/>
             <a:ext cx="4846320" cy="274320"/>
           </a:xfrm>
           <a:prstGeom prst="rect">
@@ -3729,21 +3766,21 @@
                 </a:solidFill>
                 <a:latin typeface="Aptos"/>
               </a:rPr>
-              <a:t>AI usage declaration</a:t>
-            </a:r>
-          </a:p>
-        </p:txBody>
-      </p:sp>
-      <p:sp>
-        <p:nvSpPr>
-          <p:cNvPr id="9" name="TextBox 8"/>
-          <p:cNvSpPr txBox="1"/>
-          <p:nvPr/>
-        </p:nvSpPr>
-        <p:spPr>
-          <a:xfrm>
-            <a:off x="822959" y="2212848"/>
-            <a:ext cx="4846320" cy="2331720"/>
+              <a:t>Current limitations</a:t>
+            </a:r>
+          </a:p>
+        </p:txBody>
+      </p:sp>
+      <p:sp>
+        <p:nvSpPr>
+          <p:cNvPr id="10" name="TextBox 9"/>
+          <p:cNvSpPr txBox="1"/>
+          <p:nvPr/>
+        </p:nvSpPr>
+        <p:spPr>
+          <a:xfrm>
+            <a:off x="822959" y="2670048"/>
+            <a:ext cx="4846320" cy="1783080"/>
           </a:xfrm>
           <a:prstGeom prst="rect">
             <a:avLst/>
@@ -3764,22 +3801,24 @@
                 </a:solidFill>
                 <a:latin typeface="Aptos"/>
               </a:rPr>
-              <a:t>An AI coding assistant supported the initial scaffold, service boundaries, validation engine, frontend, tests, documentation and this presentation.
-The source was reviewed and locally test-verified. Gemini is used at runtime only for evidence-backed field extraction after explicit configuration.</a:t>
-            </a:r>
-          </a:p>
-        </p:txBody>
-      </p:sp>
-      <p:sp>
-        <p:nvSpPr>
-          <p:cNvPr id="10" name="Rounded Rectangle 9"/>
+              <a:t>Render Free local SQLite storage is ephemeral.
+No authentication or rate limiting.
+Large dense documents may need chunked extraction.
+Model confidence is not independently calibrated.</a:t>
+            </a:r>
+          </a:p>
+        </p:txBody>
+      </p:sp>
+      <p:sp>
+        <p:nvSpPr>
+          <p:cNvPr id="11" name="Rounded Rectangle 10"/>
           <p:cNvSpPr/>
           <p:nvPr/>
         </p:nvSpPr>
         <p:spPr>
           <a:xfrm>
-            <a:off x="6126480" y="1691640"/>
-            <a:ext cx="5394960" cy="2971800"/>
+            <a:off x="6126480" y="2148840"/>
+            <a:ext cx="5394960" cy="2423160"/>
           </a:xfrm>
           <a:prstGeom prst="roundRect">
             <a:avLst/>
@@ -3817,6 +3856,570 @@
       </p:sp>
       <p:sp>
         <p:nvSpPr>
+          <p:cNvPr id="12" name="Rectangle 11"/>
+          <p:cNvSpPr/>
+          <p:nvPr/>
+        </p:nvSpPr>
+        <p:spPr>
+          <a:xfrm>
+            <a:off x="6126480" y="2148840"/>
+            <a:ext cx="54864" cy="2423160"/>
+          </a:xfrm>
+          <a:prstGeom prst="rect">
+            <a:avLst/>
+          </a:prstGeom>
+          <a:solidFill>
+            <a:srgbClr val="0F766E"/>
+          </a:solidFill>
+          <a:ln>
+            <a:noFill/>
+          </a:ln>
+        </p:spPr>
+        <p:style>
+          <a:lnRef idx="1">
+            <a:schemeClr val="accent1"/>
+          </a:lnRef>
+          <a:fillRef idx="3">
+            <a:schemeClr val="accent1"/>
+          </a:fillRef>
+          <a:effectRef idx="2">
+            <a:schemeClr val="accent1"/>
+          </a:effectRef>
+          <a:fontRef idx="minor">
+            <a:schemeClr val="lt1"/>
+          </a:fontRef>
+        </p:style>
+        <p:txBody>
+          <a:bodyPr rtlCol="0" anchor="ctr"/>
+          <a:lstStyle/>
+          <a:p>
+            <a:pPr algn="ctr"/>
+          </a:p>
+        </p:txBody>
+      </p:sp>
+      <p:sp>
+        <p:nvSpPr>
+          <p:cNvPr id="13" name="TextBox 12"/>
+          <p:cNvSpPr txBox="1"/>
+          <p:nvPr/>
+        </p:nvSpPr>
+        <p:spPr>
+          <a:xfrm>
+            <a:off x="6309360" y="2313432"/>
+            <a:ext cx="5074920" cy="274320"/>
+          </a:xfrm>
+          <a:prstGeom prst="rect">
+            <a:avLst/>
+          </a:prstGeom>
+          <a:noFill/>
+        </p:spPr>
+        <p:txBody>
+          <a:bodyPr wrap="square" lIns="36576" rIns="36576" tIns="36576" bIns="36576" anchor="t">
+            <a:spAutoFit/>
+          </a:bodyPr>
+          <a:lstStyle/>
+          <a:p>
+            <a:pPr algn="l"/>
+            <a:r>
+              <a:rPr sz="1300" b="1">
+                <a:solidFill>
+                  <a:srgbClr val="102C32"/>
+                </a:solidFill>
+                <a:latin typeface="Aptos"/>
+              </a:rPr>
+              <a:t>Production changes</a:t>
+            </a:r>
+          </a:p>
+        </p:txBody>
+      </p:sp>
+      <p:sp>
+        <p:nvSpPr>
+          <p:cNvPr id="14" name="TextBox 13"/>
+          <p:cNvSpPr txBox="1"/>
+          <p:nvPr/>
+        </p:nvSpPr>
+        <p:spPr>
+          <a:xfrm>
+            <a:off x="6309360" y="2670048"/>
+            <a:ext cx="5074920" cy="1783080"/>
+          </a:xfrm>
+          <a:prstGeom prst="rect">
+            <a:avLst/>
+          </a:prstGeom>
+          <a:noFill/>
+        </p:spPr>
+        <p:txBody>
+          <a:bodyPr wrap="square" lIns="36576" rIns="36576" tIns="36576" bIns="36576" anchor="t">
+            <a:spAutoFit/>
+          </a:bodyPr>
+          <a:lstStyle/>
+          <a:p>
+            <a:pPr algn="l"/>
+            <a:r>
+              <a:rPr sz="1400" b="0">
+                <a:solidFill>
+                  <a:srgbClr val="66767A"/>
+                </a:solidFill>
+                <a:latin typeface="Aptos"/>
+              </a:rPr>
+              <a:t>Managed Postgres and object storage.
+Durable worker queue and observability.
+Authentication, tenant isolation and quotas.
+Golden-document evaluations and reconciliation expansion.</a:t>
+            </a:r>
+          </a:p>
+        </p:txBody>
+      </p:sp>
+      <p:sp>
+        <p:nvSpPr>
+          <p:cNvPr id="15" name="TextBox 14"/>
+          <p:cNvSpPr txBox="1"/>
+          <p:nvPr/>
+        </p:nvSpPr>
+        <p:spPr>
+          <a:xfrm>
+            <a:off x="640080" y="5138928"/>
+            <a:ext cx="2377440" cy="256032"/>
+          </a:xfrm>
+          <a:prstGeom prst="rect">
+            <a:avLst/>
+          </a:prstGeom>
+          <a:noFill/>
+        </p:spPr>
+        <p:txBody>
+          <a:bodyPr wrap="square" lIns="36576" rIns="36576" tIns="36576" bIns="36576" anchor="t">
+            <a:spAutoFit/>
+          </a:bodyPr>
+          <a:lstStyle/>
+          <a:p>
+            <a:pPr algn="l"/>
+            <a:r>
+              <a:rPr sz="1400" b="1">
+                <a:solidFill>
+                  <a:srgbClr val="C48A38"/>
+                </a:solidFill>
+                <a:latin typeface="Aptos"/>
+              </a:rPr>
+              <a:t>Important distinction</a:t>
+            </a:r>
+          </a:p>
+        </p:txBody>
+      </p:sp>
+      <p:sp>
+        <p:nvSpPr>
+          <p:cNvPr id="16" name="TextBox 15"/>
+          <p:cNvSpPr txBox="1"/>
+          <p:nvPr/>
+        </p:nvSpPr>
+        <p:spPr>
+          <a:xfrm>
+            <a:off x="658368" y="5486400"/>
+            <a:ext cx="10332720" cy="320040"/>
+          </a:xfrm>
+          <a:prstGeom prst="rect">
+            <a:avLst/>
+          </a:prstGeom>
+          <a:noFill/>
+        </p:spPr>
+        <p:txBody>
+          <a:bodyPr wrap="square" lIns="36576" rIns="36576" tIns="36576" bIns="36576" anchor="t">
+            <a:spAutoFit/>
+          </a:bodyPr>
+          <a:lstStyle/>
+          <a:p>
+            <a:pPr algn="l"/>
+            <a:r>
+              <a:rPr sz="1600" b="0">
+                <a:solidFill>
+                  <a:srgbClr val="102C32"/>
+                </a:solidFill>
+                <a:latin typeface="Aptos"/>
+              </a:rPr>
+              <a:t>The current live extraction flow works; durable history requires a persistent database plan.</a:t>
+            </a:r>
+          </a:p>
+        </p:txBody>
+      </p:sp>
+    </p:spTree>
+  </p:cSld>
+  <p:clrMapOvr>
+    <a:masterClrMapping/>
+  </p:clrMapOvr>
+</p:sld>
+</file>
+
+<file path=ppt/slides/slide11.xml><?xml version="1.0" encoding="utf-8"?>
+<p:sld xmlns:a="http://schemas.openxmlformats.org/drawingml/2006/main" xmlns:p="http://schemas.openxmlformats.org/presentationml/2006/main" xmlns:r="http://schemas.openxmlformats.org/officeDocument/2006/relationships">
+  <p:cSld>
+    <p:bg>
+      <p:bgPr>
+        <a:solidFill>
+          <a:srgbClr val="F6F4EE"/>
+        </a:solidFill>
+        <a:effectLst/>
+      </p:bgPr>
+    </p:bg>
+    <p:spTree>
+      <p:nvGrpSpPr>
+        <p:cNvPr id="1" name=""/>
+        <p:cNvGrpSpPr/>
+        <p:nvPr/>
+      </p:nvGrpSpPr>
+      <p:grpSpPr/>
+      <p:sp>
+        <p:nvSpPr>
+          <p:cNvPr id="2" name="TextBox 1"/>
+          <p:cNvSpPr txBox="1"/>
+          <p:nvPr/>
+        </p:nvSpPr>
+        <p:spPr>
+          <a:xfrm>
+            <a:off x="594360" y="347472"/>
+            <a:ext cx="5029200" cy="228600"/>
+          </a:xfrm>
+          <a:prstGeom prst="rect">
+            <a:avLst/>
+          </a:prstGeom>
+          <a:noFill/>
+        </p:spPr>
+        <p:txBody>
+          <a:bodyPr wrap="square" lIns="36576" rIns="36576" tIns="36576" bIns="36576" anchor="t">
+            <a:spAutoFit/>
+          </a:bodyPr>
+          <a:lstStyle/>
+          <a:p>
+            <a:pPr algn="l"/>
+            <a:r>
+              <a:rPr sz="900" b="1">
+                <a:solidFill>
+                  <a:srgbClr val="0F766E"/>
+                </a:solidFill>
+                <a:latin typeface="Aptos"/>
+              </a:rPr>
+              <a:t>TRANSPARENT ENGINEERING</a:t>
+            </a:r>
+          </a:p>
+        </p:txBody>
+      </p:sp>
+      <p:sp>
+        <p:nvSpPr>
+          <p:cNvPr id="3" name="TextBox 2"/>
+          <p:cNvSpPr txBox="1"/>
+          <p:nvPr/>
+        </p:nvSpPr>
+        <p:spPr>
+          <a:xfrm>
+            <a:off x="594360" y="640080"/>
+            <a:ext cx="10607040" cy="475488"/>
+          </a:xfrm>
+          <a:prstGeom prst="rect">
+            <a:avLst/>
+          </a:prstGeom>
+          <a:noFill/>
+        </p:spPr>
+        <p:txBody>
+          <a:bodyPr wrap="square" lIns="36576" rIns="36576" tIns="36576" bIns="36576" anchor="t">
+            <a:spAutoFit/>
+          </a:bodyPr>
+          <a:lstStyle/>
+          <a:p>
+            <a:pPr algn="l"/>
+            <a:r>
+              <a:rPr sz="2700" b="1">
+                <a:solidFill>
+                  <a:srgbClr val="102C32"/>
+                </a:solidFill>
+                <a:latin typeface="Aptos"/>
+              </a:rPr>
+              <a:t>AI usage and submission deliverables</a:t>
+            </a:r>
+          </a:p>
+        </p:txBody>
+      </p:sp>
+      <p:sp>
+        <p:nvSpPr>
+          <p:cNvPr id="4" name="TextBox 3"/>
+          <p:cNvSpPr txBox="1"/>
+          <p:nvPr/>
+        </p:nvSpPr>
+        <p:spPr>
+          <a:xfrm>
+            <a:off x="8641080" y="6428232"/>
+            <a:ext cx="2926080" cy="182880"/>
+          </a:xfrm>
+          <a:prstGeom prst="rect">
+            <a:avLst/>
+          </a:prstGeom>
+          <a:noFill/>
+        </p:spPr>
+        <p:txBody>
+          <a:bodyPr wrap="square" lIns="36576" rIns="36576" tIns="36576" bIns="36576" anchor="t">
+            <a:spAutoFit/>
+          </a:bodyPr>
+          <a:lstStyle/>
+          <a:p>
+            <a:pPr algn="r"/>
+            <a:r>
+              <a:rPr sz="800" b="1">
+                <a:solidFill>
+                  <a:srgbClr val="66767A"/>
+                </a:solidFill>
+                <a:latin typeface="Aptos"/>
+              </a:rPr>
+              <a:t>11  |  DOCUMENT INTELLIGENCE PLATFORM</a:t>
+            </a:r>
+          </a:p>
+        </p:txBody>
+      </p:sp>
+      <p:sp>
+        <p:nvSpPr>
+          <p:cNvPr id="5" name="Rectangle 4"/>
+          <p:cNvSpPr/>
+          <p:nvPr/>
+        </p:nvSpPr>
+        <p:spPr>
+          <a:xfrm>
+            <a:off x="594360" y="1307592"/>
+            <a:ext cx="10972800" cy="13716"/>
+          </a:xfrm>
+          <a:prstGeom prst="rect">
+            <a:avLst/>
+          </a:prstGeom>
+          <a:solidFill>
+            <a:srgbClr val="D6E1DE"/>
+          </a:solidFill>
+          <a:ln>
+            <a:noFill/>
+          </a:ln>
+        </p:spPr>
+        <p:style>
+          <a:lnRef idx="1">
+            <a:schemeClr val="accent1"/>
+          </a:lnRef>
+          <a:fillRef idx="3">
+            <a:schemeClr val="accent1"/>
+          </a:fillRef>
+          <a:effectRef idx="2">
+            <a:schemeClr val="accent1"/>
+          </a:effectRef>
+          <a:fontRef idx="minor">
+            <a:schemeClr val="lt1"/>
+          </a:fontRef>
+        </p:style>
+        <p:txBody>
+          <a:bodyPr rtlCol="0" anchor="ctr"/>
+          <a:lstStyle/>
+          <a:p>
+            <a:pPr algn="ctr"/>
+          </a:p>
+        </p:txBody>
+      </p:sp>
+      <p:sp>
+        <p:nvSpPr>
+          <p:cNvPr id="6" name="Rounded Rectangle 5"/>
+          <p:cNvSpPr/>
+          <p:nvPr/>
+        </p:nvSpPr>
+        <p:spPr>
+          <a:xfrm>
+            <a:off x="640080" y="1691640"/>
+            <a:ext cx="5166360" cy="2971800"/>
+          </a:xfrm>
+          <a:prstGeom prst="roundRect">
+            <a:avLst/>
+          </a:prstGeom>
+          <a:solidFill>
+            <a:srgbClr val="FFFFFF"/>
+          </a:solidFill>
+          <a:ln w="10160">
+            <a:solidFill>
+              <a:srgbClr val="D6E1DE"/>
+            </a:solidFill>
+          </a:ln>
+        </p:spPr>
+        <p:style>
+          <a:lnRef idx="1">
+            <a:schemeClr val="accent1"/>
+          </a:lnRef>
+          <a:fillRef idx="3">
+            <a:schemeClr val="accent1"/>
+          </a:fillRef>
+          <a:effectRef idx="2">
+            <a:schemeClr val="accent1"/>
+          </a:effectRef>
+          <a:fontRef idx="minor">
+            <a:schemeClr val="lt1"/>
+          </a:fontRef>
+        </p:style>
+        <p:txBody>
+          <a:bodyPr rtlCol="0" anchor="ctr"/>
+          <a:lstStyle/>
+          <a:p>
+            <a:pPr algn="ctr"/>
+          </a:p>
+        </p:txBody>
+      </p:sp>
+      <p:sp>
+        <p:nvSpPr>
+          <p:cNvPr id="7" name="Rectangle 6"/>
+          <p:cNvSpPr/>
+          <p:nvPr/>
+        </p:nvSpPr>
+        <p:spPr>
+          <a:xfrm>
+            <a:off x="640080" y="1691640"/>
+            <a:ext cx="54864" cy="2971800"/>
+          </a:xfrm>
+          <a:prstGeom prst="rect">
+            <a:avLst/>
+          </a:prstGeom>
+          <a:solidFill>
+            <a:srgbClr val="0F766E"/>
+          </a:solidFill>
+          <a:ln>
+            <a:noFill/>
+          </a:ln>
+        </p:spPr>
+        <p:style>
+          <a:lnRef idx="1">
+            <a:schemeClr val="accent1"/>
+          </a:lnRef>
+          <a:fillRef idx="3">
+            <a:schemeClr val="accent1"/>
+          </a:fillRef>
+          <a:effectRef idx="2">
+            <a:schemeClr val="accent1"/>
+          </a:effectRef>
+          <a:fontRef idx="minor">
+            <a:schemeClr val="lt1"/>
+          </a:fontRef>
+        </p:style>
+        <p:txBody>
+          <a:bodyPr rtlCol="0" anchor="ctr"/>
+          <a:lstStyle/>
+          <a:p>
+            <a:pPr algn="ctr"/>
+          </a:p>
+        </p:txBody>
+      </p:sp>
+      <p:sp>
+        <p:nvSpPr>
+          <p:cNvPr id="8" name="TextBox 7"/>
+          <p:cNvSpPr txBox="1"/>
+          <p:nvPr/>
+        </p:nvSpPr>
+        <p:spPr>
+          <a:xfrm>
+            <a:off x="822959" y="1856232"/>
+            <a:ext cx="4846320" cy="274320"/>
+          </a:xfrm>
+          <a:prstGeom prst="rect">
+            <a:avLst/>
+          </a:prstGeom>
+          <a:noFill/>
+        </p:spPr>
+        <p:txBody>
+          <a:bodyPr wrap="square" lIns="36576" rIns="36576" tIns="36576" bIns="36576" anchor="t">
+            <a:spAutoFit/>
+          </a:bodyPr>
+          <a:lstStyle/>
+          <a:p>
+            <a:pPr algn="l"/>
+            <a:r>
+              <a:rPr sz="1300" b="1">
+                <a:solidFill>
+                  <a:srgbClr val="102C32"/>
+                </a:solidFill>
+                <a:latin typeface="Aptos"/>
+              </a:rPr>
+              <a:t>AI usage declaration</a:t>
+            </a:r>
+          </a:p>
+        </p:txBody>
+      </p:sp>
+      <p:sp>
+        <p:nvSpPr>
+          <p:cNvPr id="9" name="TextBox 8"/>
+          <p:cNvSpPr txBox="1"/>
+          <p:nvPr/>
+        </p:nvSpPr>
+        <p:spPr>
+          <a:xfrm>
+            <a:off x="822959" y="2212848"/>
+            <a:ext cx="4846320" cy="2331720"/>
+          </a:xfrm>
+          <a:prstGeom prst="rect">
+            <a:avLst/>
+          </a:prstGeom>
+          <a:noFill/>
+        </p:spPr>
+        <p:txBody>
+          <a:bodyPr wrap="square" lIns="36576" rIns="36576" tIns="36576" bIns="36576" anchor="t">
+            <a:spAutoFit/>
+          </a:bodyPr>
+          <a:lstStyle/>
+          <a:p>
+            <a:pPr algn="l"/>
+            <a:r>
+              <a:rPr sz="1400" b="0">
+                <a:solidFill>
+                  <a:srgbClr val="66767A"/>
+                </a:solidFill>
+                <a:latin typeface="Aptos"/>
+              </a:rPr>
+              <a:t>An AI coding assistant supported the initial scaffold, service boundaries, validation engine, frontend, tests, documentation and this presentation.
+The source was reviewed and locally test-verified. Gemini is used at runtime only for evidence-backed field extraction after explicit configuration.</a:t>
+            </a:r>
+          </a:p>
+        </p:txBody>
+      </p:sp>
+      <p:sp>
+        <p:nvSpPr>
+          <p:cNvPr id="10" name="Rounded Rectangle 9"/>
+          <p:cNvSpPr/>
+          <p:nvPr/>
+        </p:nvSpPr>
+        <p:spPr>
+          <a:xfrm>
+            <a:off x="6126480" y="1691640"/>
+            <a:ext cx="5394960" cy="2971800"/>
+          </a:xfrm>
+          <a:prstGeom prst="roundRect">
+            <a:avLst/>
+          </a:prstGeom>
+          <a:solidFill>
+            <a:srgbClr val="FFFFFF"/>
+          </a:solidFill>
+          <a:ln w="10160">
+            <a:solidFill>
+              <a:srgbClr val="D6E1DE"/>
+            </a:solidFill>
+          </a:ln>
+        </p:spPr>
+        <p:style>
+          <a:lnRef idx="1">
+            <a:schemeClr val="accent1"/>
+          </a:lnRef>
+          <a:fillRef idx="3">
+            <a:schemeClr val="accent1"/>
+          </a:fillRef>
+          <a:effectRef idx="2">
+            <a:schemeClr val="accent1"/>
+          </a:effectRef>
+          <a:fontRef idx="minor">
+            <a:schemeClr val="lt1"/>
+          </a:fontRef>
+        </p:style>
+        <p:txBody>
+          <a:bodyPr rtlCol="0" anchor="ctr"/>
+          <a:lstStyle/>
+          <a:p>
+            <a:pPr algn="ctr"/>
+          </a:p>
+        </p:txBody>
+      </p:sp>
+      <p:sp>
+        <p:nvSpPr>
           <p:cNvPr id="11" name="Rectangle 10"/>
           <p:cNvSpPr/>
           <p:nvPr/>
@@ -3999,6 +4602,955 @@
                 <a:latin typeface="Aptos"/>
               </a:rPr>
               <a:t>Live app: document-intelligence-platform-kace.onrender.com</a:t>
+            </a:r>
+          </a:p>
+        </p:txBody>
+      </p:sp>
+    </p:spTree>
+  </p:cSld>
+  <p:clrMapOvr>
+    <a:masterClrMapping/>
+  </p:clrMapOvr>
+</p:sld>
+</file>
+
+<file path=ppt/slides/slide12.xml><?xml version="1.0" encoding="utf-8"?>
+<p:sld xmlns:a="http://schemas.openxmlformats.org/drawingml/2006/main" xmlns:p="http://schemas.openxmlformats.org/presentationml/2006/main" xmlns:r="http://schemas.openxmlformats.org/officeDocument/2006/relationships">
+  <p:cSld>
+    <p:bg>
+      <p:bgPr>
+        <a:solidFill>
+          <a:srgbClr val="F6F4EE"/>
+        </a:solidFill>
+        <a:effectLst/>
+      </p:bgPr>
+    </p:bg>
+    <p:spTree>
+      <p:nvGrpSpPr>
+        <p:cNvPr id="1" name=""/>
+        <p:cNvGrpSpPr/>
+        <p:nvPr/>
+      </p:nvGrpSpPr>
+      <p:grpSpPr/>
+      <p:sp>
+        <p:nvSpPr>
+          <p:cNvPr id="2" name="TextBox 1"/>
+          <p:cNvSpPr txBox="1"/>
+          <p:nvPr/>
+        </p:nvSpPr>
+        <p:spPr>
+          <a:xfrm>
+            <a:off x="594360" y="347472"/>
+            <a:ext cx="5029200" cy="228600"/>
+          </a:xfrm>
+          <a:prstGeom prst="rect">
+            <a:avLst/>
+          </a:prstGeom>
+          <a:noFill/>
+        </p:spPr>
+        <p:txBody>
+          <a:bodyPr wrap="square" lIns="36576" rIns="36576" tIns="36576" bIns="36576" anchor="t">
+            <a:spAutoFit/>
+          </a:bodyPr>
+          <a:lstStyle/>
+          <a:p>
+            <a:pPr algn="l"/>
+            <a:r>
+              <a:rPr sz="900" b="1">
+                <a:solidFill>
+                  <a:srgbClr val="0F766E"/>
+                </a:solidFill>
+                <a:latin typeface="Aptos"/>
+              </a:rPr>
+              <a:t>SIX-MINUTE WALKTHROUGH</a:t>
+            </a:r>
+          </a:p>
+        </p:txBody>
+      </p:sp>
+      <p:sp>
+        <p:nvSpPr>
+          <p:cNvPr id="3" name="TextBox 2"/>
+          <p:cNvSpPr txBox="1"/>
+          <p:nvPr/>
+        </p:nvSpPr>
+        <p:spPr>
+          <a:xfrm>
+            <a:off x="594360" y="640080"/>
+            <a:ext cx="10607040" cy="475488"/>
+          </a:xfrm>
+          <a:prstGeom prst="rect">
+            <a:avLst/>
+          </a:prstGeom>
+          <a:noFill/>
+        </p:spPr>
+        <p:txBody>
+          <a:bodyPr wrap="square" lIns="36576" rIns="36576" tIns="36576" bIns="36576" anchor="t">
+            <a:spAutoFit/>
+          </a:bodyPr>
+          <a:lstStyle/>
+          <a:p>
+            <a:pPr algn="l"/>
+            <a:r>
+              <a:rPr sz="2700" b="1">
+                <a:solidFill>
+                  <a:srgbClr val="102C32"/>
+                </a:solidFill>
+                <a:latin typeface="Aptos"/>
+              </a:rPr>
+              <a:t>How to present the live demo</a:t>
+            </a:r>
+          </a:p>
+        </p:txBody>
+      </p:sp>
+      <p:sp>
+        <p:nvSpPr>
+          <p:cNvPr id="4" name="TextBox 3"/>
+          <p:cNvSpPr txBox="1"/>
+          <p:nvPr/>
+        </p:nvSpPr>
+        <p:spPr>
+          <a:xfrm>
+            <a:off x="8641080" y="6428232"/>
+            <a:ext cx="2926080" cy="182880"/>
+          </a:xfrm>
+          <a:prstGeom prst="rect">
+            <a:avLst/>
+          </a:prstGeom>
+          <a:noFill/>
+        </p:spPr>
+        <p:txBody>
+          <a:bodyPr wrap="square" lIns="36576" rIns="36576" tIns="36576" bIns="36576" anchor="t">
+            <a:spAutoFit/>
+          </a:bodyPr>
+          <a:lstStyle/>
+          <a:p>
+            <a:pPr algn="r"/>
+            <a:r>
+              <a:rPr sz="800" b="1">
+                <a:solidFill>
+                  <a:srgbClr val="66767A"/>
+                </a:solidFill>
+                <a:latin typeface="Aptos"/>
+              </a:rPr>
+              <a:t>12  |  DOCUMENT INTELLIGENCE PLATFORM</a:t>
+            </a:r>
+          </a:p>
+        </p:txBody>
+      </p:sp>
+      <p:sp>
+        <p:nvSpPr>
+          <p:cNvPr id="5" name="Rectangle 4"/>
+          <p:cNvSpPr/>
+          <p:nvPr/>
+        </p:nvSpPr>
+        <p:spPr>
+          <a:xfrm>
+            <a:off x="594360" y="1307592"/>
+            <a:ext cx="10972800" cy="13716"/>
+          </a:xfrm>
+          <a:prstGeom prst="rect">
+            <a:avLst/>
+          </a:prstGeom>
+          <a:solidFill>
+            <a:srgbClr val="D6E1DE"/>
+          </a:solidFill>
+          <a:ln>
+            <a:noFill/>
+          </a:ln>
+        </p:spPr>
+        <p:style>
+          <a:lnRef idx="1">
+            <a:schemeClr val="accent1"/>
+          </a:lnRef>
+          <a:fillRef idx="3">
+            <a:schemeClr val="accent1"/>
+          </a:fillRef>
+          <a:effectRef idx="2">
+            <a:schemeClr val="accent1"/>
+          </a:effectRef>
+          <a:fontRef idx="minor">
+            <a:schemeClr val="lt1"/>
+          </a:fontRef>
+        </p:style>
+        <p:txBody>
+          <a:bodyPr rtlCol="0" anchor="ctr"/>
+          <a:lstStyle/>
+          <a:p>
+            <a:pPr algn="ctr"/>
+          </a:p>
+        </p:txBody>
+      </p:sp>
+      <p:sp>
+        <p:nvSpPr>
+          <p:cNvPr id="6" name="Oval 5"/>
+          <p:cNvSpPr/>
+          <p:nvPr/>
+        </p:nvSpPr>
+        <p:spPr>
+          <a:xfrm>
+            <a:off x="658368" y="1572768"/>
+            <a:ext cx="438912" cy="438912"/>
+          </a:xfrm>
+          <a:prstGeom prst="ellipse">
+            <a:avLst/>
+          </a:prstGeom>
+          <a:solidFill>
+            <a:srgbClr val="0F766E"/>
+          </a:solidFill>
+          <a:ln>
+            <a:noFill/>
+          </a:ln>
+        </p:spPr>
+        <p:style>
+          <a:lnRef idx="1">
+            <a:schemeClr val="accent1"/>
+          </a:lnRef>
+          <a:fillRef idx="3">
+            <a:schemeClr val="accent1"/>
+          </a:fillRef>
+          <a:effectRef idx="2">
+            <a:schemeClr val="accent1"/>
+          </a:effectRef>
+          <a:fontRef idx="minor">
+            <a:schemeClr val="lt1"/>
+          </a:fontRef>
+        </p:style>
+        <p:txBody>
+          <a:bodyPr rtlCol="0" anchor="ctr"/>
+          <a:lstStyle/>
+          <a:p>
+            <a:pPr algn="ctr"/>
+          </a:p>
+        </p:txBody>
+      </p:sp>
+      <p:sp>
+        <p:nvSpPr>
+          <p:cNvPr id="7" name="TextBox 6"/>
+          <p:cNvSpPr txBox="1"/>
+          <p:nvPr/>
+        </p:nvSpPr>
+        <p:spPr>
+          <a:xfrm>
+            <a:off x="658368" y="1682495"/>
+            <a:ext cx="438912" cy="164592"/>
+          </a:xfrm>
+          <a:prstGeom prst="rect">
+            <a:avLst/>
+          </a:prstGeom>
+          <a:noFill/>
+        </p:spPr>
+        <p:txBody>
+          <a:bodyPr wrap="square" lIns="36576" rIns="36576" tIns="36576" bIns="36576" anchor="t">
+            <a:spAutoFit/>
+          </a:bodyPr>
+          <a:lstStyle/>
+          <a:p>
+            <a:pPr algn="ctr"/>
+            <a:r>
+              <a:rPr sz="900" b="1">
+                <a:solidFill>
+                  <a:srgbClr val="FFFFFF"/>
+                </a:solidFill>
+                <a:latin typeface="Aptos"/>
+              </a:rPr>
+              <a:t>01</a:t>
+            </a:r>
+          </a:p>
+        </p:txBody>
+      </p:sp>
+      <p:sp>
+        <p:nvSpPr>
+          <p:cNvPr id="8" name="TextBox 7"/>
+          <p:cNvSpPr txBox="1"/>
+          <p:nvPr/>
+        </p:nvSpPr>
+        <p:spPr>
+          <a:xfrm>
+            <a:off x="1280160" y="1600200"/>
+            <a:ext cx="3794760" cy="228600"/>
+          </a:xfrm>
+          <a:prstGeom prst="rect">
+            <a:avLst/>
+          </a:prstGeom>
+          <a:noFill/>
+        </p:spPr>
+        <p:txBody>
+          <a:bodyPr wrap="square" lIns="36576" rIns="36576" tIns="36576" bIns="36576" anchor="t">
+            <a:spAutoFit/>
+          </a:bodyPr>
+          <a:lstStyle/>
+          <a:p>
+            <a:pPr algn="l"/>
+            <a:r>
+              <a:rPr sz="1400" b="1">
+                <a:solidFill>
+                  <a:srgbClr val="102C32"/>
+                </a:solidFill>
+                <a:latin typeface="Aptos"/>
+              </a:rPr>
+              <a:t>Open the live Ledger dashboard</a:t>
+            </a:r>
+          </a:p>
+        </p:txBody>
+      </p:sp>
+      <p:sp>
+        <p:nvSpPr>
+          <p:cNvPr id="9" name="TextBox 8"/>
+          <p:cNvSpPr txBox="1"/>
+          <p:nvPr/>
+        </p:nvSpPr>
+        <p:spPr>
+          <a:xfrm>
+            <a:off x="5120640" y="1600200"/>
+            <a:ext cx="6080760" cy="347472"/>
+          </a:xfrm>
+          <a:prstGeom prst="rect">
+            <a:avLst/>
+          </a:prstGeom>
+          <a:noFill/>
+        </p:spPr>
+        <p:txBody>
+          <a:bodyPr wrap="square" lIns="36576" rIns="36576" tIns="36576" bIns="36576" anchor="t">
+            <a:spAutoFit/>
+          </a:bodyPr>
+          <a:lstStyle/>
+          <a:p>
+            <a:pPr algn="l"/>
+            <a:r>
+              <a:rPr sz="1300" b="0">
+                <a:solidFill>
+                  <a:srgbClr val="66767A"/>
+                </a:solidFill>
+                <a:latin typeface="Aptos"/>
+              </a:rPr>
+              <a:t>State the problem: financial documents are unstructured and hard to review.</a:t>
+            </a:r>
+          </a:p>
+        </p:txBody>
+      </p:sp>
+      <p:sp>
+        <p:nvSpPr>
+          <p:cNvPr id="10" name="Oval 9"/>
+          <p:cNvSpPr/>
+          <p:nvPr/>
+        </p:nvSpPr>
+        <p:spPr>
+          <a:xfrm>
+            <a:off x="658368" y="2377440"/>
+            <a:ext cx="438912" cy="438912"/>
+          </a:xfrm>
+          <a:prstGeom prst="ellipse">
+            <a:avLst/>
+          </a:prstGeom>
+          <a:solidFill>
+            <a:srgbClr val="0F766E"/>
+          </a:solidFill>
+          <a:ln>
+            <a:noFill/>
+          </a:ln>
+        </p:spPr>
+        <p:style>
+          <a:lnRef idx="1">
+            <a:schemeClr val="accent1"/>
+          </a:lnRef>
+          <a:fillRef idx="3">
+            <a:schemeClr val="accent1"/>
+          </a:fillRef>
+          <a:effectRef idx="2">
+            <a:schemeClr val="accent1"/>
+          </a:effectRef>
+          <a:fontRef idx="minor">
+            <a:schemeClr val="lt1"/>
+          </a:fontRef>
+        </p:style>
+        <p:txBody>
+          <a:bodyPr rtlCol="0" anchor="ctr"/>
+          <a:lstStyle/>
+          <a:p>
+            <a:pPr algn="ctr"/>
+          </a:p>
+        </p:txBody>
+      </p:sp>
+      <p:sp>
+        <p:nvSpPr>
+          <p:cNvPr id="11" name="TextBox 10"/>
+          <p:cNvSpPr txBox="1"/>
+          <p:nvPr/>
+        </p:nvSpPr>
+        <p:spPr>
+          <a:xfrm>
+            <a:off x="658368" y="2487168"/>
+            <a:ext cx="438912" cy="164592"/>
+          </a:xfrm>
+          <a:prstGeom prst="rect">
+            <a:avLst/>
+          </a:prstGeom>
+          <a:noFill/>
+        </p:spPr>
+        <p:txBody>
+          <a:bodyPr wrap="square" lIns="36576" rIns="36576" tIns="36576" bIns="36576" anchor="t">
+            <a:spAutoFit/>
+          </a:bodyPr>
+          <a:lstStyle/>
+          <a:p>
+            <a:pPr algn="ctr"/>
+            <a:r>
+              <a:rPr sz="900" b="1">
+                <a:solidFill>
+                  <a:srgbClr val="FFFFFF"/>
+                </a:solidFill>
+                <a:latin typeface="Aptos"/>
+              </a:rPr>
+              <a:t>02</a:t>
+            </a:r>
+          </a:p>
+        </p:txBody>
+      </p:sp>
+      <p:sp>
+        <p:nvSpPr>
+          <p:cNvPr id="12" name="TextBox 11"/>
+          <p:cNvSpPr txBox="1"/>
+          <p:nvPr/>
+        </p:nvSpPr>
+        <p:spPr>
+          <a:xfrm>
+            <a:off x="1280160" y="2404872"/>
+            <a:ext cx="3794760" cy="228600"/>
+          </a:xfrm>
+          <a:prstGeom prst="rect">
+            <a:avLst/>
+          </a:prstGeom>
+          <a:noFill/>
+        </p:spPr>
+        <p:txBody>
+          <a:bodyPr wrap="square" lIns="36576" rIns="36576" tIns="36576" bIns="36576" anchor="t">
+            <a:spAutoFit/>
+          </a:bodyPr>
+          <a:lstStyle/>
+          <a:p>
+            <a:pPr algn="l"/>
+            <a:r>
+              <a:rPr sz="1400" b="1">
+                <a:solidFill>
+                  <a:srgbClr val="102C32"/>
+                </a:solidFill>
+                <a:latin typeface="Aptos"/>
+              </a:rPr>
+              <a:t>Choose a document type and upload</a:t>
+            </a:r>
+          </a:p>
+        </p:txBody>
+      </p:sp>
+      <p:sp>
+        <p:nvSpPr>
+          <p:cNvPr id="13" name="TextBox 12"/>
+          <p:cNvSpPr txBox="1"/>
+          <p:nvPr/>
+        </p:nvSpPr>
+        <p:spPr>
+          <a:xfrm>
+            <a:off x="5120640" y="2404872"/>
+            <a:ext cx="6080760" cy="347472"/>
+          </a:xfrm>
+          <a:prstGeom prst="rect">
+            <a:avLst/>
+          </a:prstGeom>
+          <a:noFill/>
+        </p:spPr>
+        <p:txBody>
+          <a:bodyPr wrap="square" lIns="36576" rIns="36576" tIns="36576" bIns="36576" anchor="t">
+            <a:spAutoFit/>
+          </a:bodyPr>
+          <a:lstStyle/>
+          <a:p>
+            <a:pPr algn="l"/>
+            <a:r>
+              <a:rPr sz="1300" b="0">
+                <a:solidFill>
+                  <a:srgbClr val="66767A"/>
+                </a:solidFill>
+                <a:latin typeface="Aptos"/>
+              </a:rPr>
+              <a:t>Point out PDF/JPG/PNG support, page limit and validation before AI.</a:t>
+            </a:r>
+          </a:p>
+        </p:txBody>
+      </p:sp>
+      <p:sp>
+        <p:nvSpPr>
+          <p:cNvPr id="14" name="Oval 13"/>
+          <p:cNvSpPr/>
+          <p:nvPr/>
+        </p:nvSpPr>
+        <p:spPr>
+          <a:xfrm>
+            <a:off x="658368" y="3182112"/>
+            <a:ext cx="438912" cy="438912"/>
+          </a:xfrm>
+          <a:prstGeom prst="ellipse">
+            <a:avLst/>
+          </a:prstGeom>
+          <a:solidFill>
+            <a:srgbClr val="0F766E"/>
+          </a:solidFill>
+          <a:ln>
+            <a:noFill/>
+          </a:ln>
+        </p:spPr>
+        <p:style>
+          <a:lnRef idx="1">
+            <a:schemeClr val="accent1"/>
+          </a:lnRef>
+          <a:fillRef idx="3">
+            <a:schemeClr val="accent1"/>
+          </a:fillRef>
+          <a:effectRef idx="2">
+            <a:schemeClr val="accent1"/>
+          </a:effectRef>
+          <a:fontRef idx="minor">
+            <a:schemeClr val="lt1"/>
+          </a:fontRef>
+        </p:style>
+        <p:txBody>
+          <a:bodyPr rtlCol="0" anchor="ctr"/>
+          <a:lstStyle/>
+          <a:p>
+            <a:pPr algn="ctr"/>
+          </a:p>
+        </p:txBody>
+      </p:sp>
+      <p:sp>
+        <p:nvSpPr>
+          <p:cNvPr id="15" name="TextBox 14"/>
+          <p:cNvSpPr txBox="1"/>
+          <p:nvPr/>
+        </p:nvSpPr>
+        <p:spPr>
+          <a:xfrm>
+            <a:off x="658368" y="3291840"/>
+            <a:ext cx="438912" cy="164592"/>
+          </a:xfrm>
+          <a:prstGeom prst="rect">
+            <a:avLst/>
+          </a:prstGeom>
+          <a:noFill/>
+        </p:spPr>
+        <p:txBody>
+          <a:bodyPr wrap="square" lIns="36576" rIns="36576" tIns="36576" bIns="36576" anchor="t">
+            <a:spAutoFit/>
+          </a:bodyPr>
+          <a:lstStyle/>
+          <a:p>
+            <a:pPr algn="ctr"/>
+            <a:r>
+              <a:rPr sz="900" b="1">
+                <a:solidFill>
+                  <a:srgbClr val="FFFFFF"/>
+                </a:solidFill>
+                <a:latin typeface="Aptos"/>
+              </a:rPr>
+              <a:t>03</a:t>
+            </a:r>
+          </a:p>
+        </p:txBody>
+      </p:sp>
+      <p:sp>
+        <p:nvSpPr>
+          <p:cNvPr id="16" name="TextBox 15"/>
+          <p:cNvSpPr txBox="1"/>
+          <p:nvPr/>
+        </p:nvSpPr>
+        <p:spPr>
+          <a:xfrm>
+            <a:off x="1280160" y="3209544"/>
+            <a:ext cx="3794760" cy="228600"/>
+          </a:xfrm>
+          <a:prstGeom prst="rect">
+            <a:avLst/>
+          </a:prstGeom>
+          <a:noFill/>
+        </p:spPr>
+        <p:txBody>
+          <a:bodyPr wrap="square" lIns="36576" rIns="36576" tIns="36576" bIns="36576" anchor="t">
+            <a:spAutoFit/>
+          </a:bodyPr>
+          <a:lstStyle/>
+          <a:p>
+            <a:pPr algn="l"/>
+            <a:r>
+              <a:rPr sz="1400" b="1">
+                <a:solidFill>
+                  <a:srgbClr val="102C32"/>
+                </a:solidFill>
+                <a:latin typeface="Aptos"/>
+              </a:rPr>
+              <a:t>Explain the processing path</a:t>
+            </a:r>
+          </a:p>
+        </p:txBody>
+      </p:sp>
+      <p:sp>
+        <p:nvSpPr>
+          <p:cNvPr id="17" name="TextBox 16"/>
+          <p:cNvSpPr txBox="1"/>
+          <p:nvPr/>
+        </p:nvSpPr>
+        <p:spPr>
+          <a:xfrm>
+            <a:off x="5120640" y="3209544"/>
+            <a:ext cx="6080760" cy="347472"/>
+          </a:xfrm>
+          <a:prstGeom prst="rect">
+            <a:avLst/>
+          </a:prstGeom>
+          <a:noFill/>
+        </p:spPr>
+        <p:txBody>
+          <a:bodyPr wrap="square" lIns="36576" rIns="36576" tIns="36576" bIns="36576" anchor="t">
+            <a:spAutoFit/>
+          </a:bodyPr>
+          <a:lstStyle/>
+          <a:p>
+            <a:pPr algn="l"/>
+            <a:r>
+              <a:rPr sz="1300" b="0">
+                <a:solidFill>
+                  <a:srgbClr val="66767A"/>
+                </a:solidFill>
+                <a:latin typeface="Aptos"/>
+              </a:rPr>
+              <a:t>Validation -&gt; OCR -&gt; Gemini extraction -&gt; financial reconciliation -&gt; persisted result.</a:t>
+            </a:r>
+          </a:p>
+        </p:txBody>
+      </p:sp>
+      <p:sp>
+        <p:nvSpPr>
+          <p:cNvPr id="18" name="Oval 17"/>
+          <p:cNvSpPr/>
+          <p:nvPr/>
+        </p:nvSpPr>
+        <p:spPr>
+          <a:xfrm>
+            <a:off x="658368" y="3986784"/>
+            <a:ext cx="438912" cy="438912"/>
+          </a:xfrm>
+          <a:prstGeom prst="ellipse">
+            <a:avLst/>
+          </a:prstGeom>
+          <a:solidFill>
+            <a:srgbClr val="0F766E"/>
+          </a:solidFill>
+          <a:ln>
+            <a:noFill/>
+          </a:ln>
+        </p:spPr>
+        <p:style>
+          <a:lnRef idx="1">
+            <a:schemeClr val="accent1"/>
+          </a:lnRef>
+          <a:fillRef idx="3">
+            <a:schemeClr val="accent1"/>
+          </a:fillRef>
+          <a:effectRef idx="2">
+            <a:schemeClr val="accent1"/>
+          </a:effectRef>
+          <a:fontRef idx="minor">
+            <a:schemeClr val="lt1"/>
+          </a:fontRef>
+        </p:style>
+        <p:txBody>
+          <a:bodyPr rtlCol="0" anchor="ctr"/>
+          <a:lstStyle/>
+          <a:p>
+            <a:pPr algn="ctr"/>
+          </a:p>
+        </p:txBody>
+      </p:sp>
+      <p:sp>
+        <p:nvSpPr>
+          <p:cNvPr id="19" name="TextBox 18"/>
+          <p:cNvSpPr txBox="1"/>
+          <p:nvPr/>
+        </p:nvSpPr>
+        <p:spPr>
+          <a:xfrm>
+            <a:off x="658368" y="4096512"/>
+            <a:ext cx="438912" cy="164592"/>
+          </a:xfrm>
+          <a:prstGeom prst="rect">
+            <a:avLst/>
+          </a:prstGeom>
+          <a:noFill/>
+        </p:spPr>
+        <p:txBody>
+          <a:bodyPr wrap="square" lIns="36576" rIns="36576" tIns="36576" bIns="36576" anchor="t">
+            <a:spAutoFit/>
+          </a:bodyPr>
+          <a:lstStyle/>
+          <a:p>
+            <a:pPr algn="ctr"/>
+            <a:r>
+              <a:rPr sz="900" b="1">
+                <a:solidFill>
+                  <a:srgbClr val="FFFFFF"/>
+                </a:solidFill>
+                <a:latin typeface="Aptos"/>
+              </a:rPr>
+              <a:t>04</a:t>
+            </a:r>
+          </a:p>
+        </p:txBody>
+      </p:sp>
+      <p:sp>
+        <p:nvSpPr>
+          <p:cNvPr id="20" name="TextBox 19"/>
+          <p:cNvSpPr txBox="1"/>
+          <p:nvPr/>
+        </p:nvSpPr>
+        <p:spPr>
+          <a:xfrm>
+            <a:off x="1280160" y="4014216"/>
+            <a:ext cx="3794760" cy="228600"/>
+          </a:xfrm>
+          <a:prstGeom prst="rect">
+            <a:avLst/>
+          </a:prstGeom>
+          <a:noFill/>
+        </p:spPr>
+        <p:txBody>
+          <a:bodyPr wrap="square" lIns="36576" rIns="36576" tIns="36576" bIns="36576" anchor="t">
+            <a:spAutoFit/>
+          </a:bodyPr>
+          <a:lstStyle/>
+          <a:p>
+            <a:pPr algn="l"/>
+            <a:r>
+              <a:rPr sz="1400" b="1">
+                <a:solidFill>
+                  <a:srgbClr val="102C32"/>
+                </a:solidFill>
+                <a:latin typeface="Aptos"/>
+              </a:rPr>
+              <a:t>Open the processed document</a:t>
+            </a:r>
+          </a:p>
+        </p:txBody>
+      </p:sp>
+      <p:sp>
+        <p:nvSpPr>
+          <p:cNvPr id="21" name="TextBox 20"/>
+          <p:cNvSpPr txBox="1"/>
+          <p:nvPr/>
+        </p:nvSpPr>
+        <p:spPr>
+          <a:xfrm>
+            <a:off x="5120640" y="4014216"/>
+            <a:ext cx="6080760" cy="347472"/>
+          </a:xfrm>
+          <a:prstGeom prst="rect">
+            <a:avLst/>
+          </a:prstGeom>
+          <a:noFill/>
+        </p:spPr>
+        <p:txBody>
+          <a:bodyPr wrap="square" lIns="36576" rIns="36576" tIns="36576" bIns="36576" anchor="t">
+            <a:spAutoFit/>
+          </a:bodyPr>
+          <a:lstStyle/>
+          <a:p>
+            <a:pPr algn="l"/>
+            <a:r>
+              <a:rPr sz="1300" b="0">
+                <a:solidFill>
+                  <a:srgbClr val="66767A"/>
+                </a:solidFill>
+                <a:latin typeface="Aptos"/>
+              </a:rPr>
+              <a:t>Show fields, evidence, line items, validation checks and raw JSON.</a:t>
+            </a:r>
+          </a:p>
+        </p:txBody>
+      </p:sp>
+      <p:sp>
+        <p:nvSpPr>
+          <p:cNvPr id="22" name="Oval 21"/>
+          <p:cNvSpPr/>
+          <p:nvPr/>
+        </p:nvSpPr>
+        <p:spPr>
+          <a:xfrm>
+            <a:off x="658368" y="4791456"/>
+            <a:ext cx="438912" cy="438912"/>
+          </a:xfrm>
+          <a:prstGeom prst="ellipse">
+            <a:avLst/>
+          </a:prstGeom>
+          <a:solidFill>
+            <a:srgbClr val="0F766E"/>
+          </a:solidFill>
+          <a:ln>
+            <a:noFill/>
+          </a:ln>
+        </p:spPr>
+        <p:style>
+          <a:lnRef idx="1">
+            <a:schemeClr val="accent1"/>
+          </a:lnRef>
+          <a:fillRef idx="3">
+            <a:schemeClr val="accent1"/>
+          </a:fillRef>
+          <a:effectRef idx="2">
+            <a:schemeClr val="accent1"/>
+          </a:effectRef>
+          <a:fontRef idx="minor">
+            <a:schemeClr val="lt1"/>
+          </a:fontRef>
+        </p:style>
+        <p:txBody>
+          <a:bodyPr rtlCol="0" anchor="ctr"/>
+          <a:lstStyle/>
+          <a:p>
+            <a:pPr algn="ctr"/>
+          </a:p>
+        </p:txBody>
+      </p:sp>
+      <p:sp>
+        <p:nvSpPr>
+          <p:cNvPr id="23" name="TextBox 22"/>
+          <p:cNvSpPr txBox="1"/>
+          <p:nvPr/>
+        </p:nvSpPr>
+        <p:spPr>
+          <a:xfrm>
+            <a:off x="658368" y="4901184"/>
+            <a:ext cx="438912" cy="164592"/>
+          </a:xfrm>
+          <a:prstGeom prst="rect">
+            <a:avLst/>
+          </a:prstGeom>
+          <a:noFill/>
+        </p:spPr>
+        <p:txBody>
+          <a:bodyPr wrap="square" lIns="36576" rIns="36576" tIns="36576" bIns="36576" anchor="t">
+            <a:spAutoFit/>
+          </a:bodyPr>
+          <a:lstStyle/>
+          <a:p>
+            <a:pPr algn="ctr"/>
+            <a:r>
+              <a:rPr sz="900" b="1">
+                <a:solidFill>
+                  <a:srgbClr val="FFFFFF"/>
+                </a:solidFill>
+                <a:latin typeface="Aptos"/>
+              </a:rPr>
+              <a:t>05</a:t>
+            </a:r>
+          </a:p>
+        </p:txBody>
+      </p:sp>
+      <p:sp>
+        <p:nvSpPr>
+          <p:cNvPr id="24" name="TextBox 23"/>
+          <p:cNvSpPr txBox="1"/>
+          <p:nvPr/>
+        </p:nvSpPr>
+        <p:spPr>
+          <a:xfrm>
+            <a:off x="1280160" y="4818888"/>
+            <a:ext cx="3794760" cy="228600"/>
+          </a:xfrm>
+          <a:prstGeom prst="rect">
+            <a:avLst/>
+          </a:prstGeom>
+          <a:noFill/>
+        </p:spPr>
+        <p:txBody>
+          <a:bodyPr wrap="square" lIns="36576" rIns="36576" tIns="36576" bIns="36576" anchor="t">
+            <a:spAutoFit/>
+          </a:bodyPr>
+          <a:lstStyle/>
+          <a:p>
+            <a:pPr algn="l"/>
+            <a:r>
+              <a:rPr sz="1400" b="1">
+                <a:solidFill>
+                  <a:srgbClr val="102C32"/>
+                </a:solidFill>
+                <a:latin typeface="Aptos"/>
+              </a:rPr>
+              <a:t>Close with assurance</a:t>
+            </a:r>
+          </a:p>
+        </p:txBody>
+      </p:sp>
+      <p:sp>
+        <p:nvSpPr>
+          <p:cNvPr id="25" name="TextBox 24"/>
+          <p:cNvSpPr txBox="1"/>
+          <p:nvPr/>
+        </p:nvSpPr>
+        <p:spPr>
+          <a:xfrm>
+            <a:off x="5120640" y="4818888"/>
+            <a:ext cx="6080760" cy="347472"/>
+          </a:xfrm>
+          <a:prstGeom prst="rect">
+            <a:avLst/>
+          </a:prstGeom>
+          <a:noFill/>
+        </p:spPr>
+        <p:txBody>
+          <a:bodyPr wrap="square" lIns="36576" rIns="36576" tIns="36576" bIns="36576" anchor="t">
+            <a:spAutoFit/>
+          </a:bodyPr>
+          <a:lstStyle/>
+          <a:p>
+            <a:pPr algn="l"/>
+            <a:r>
+              <a:rPr sz="1300" b="0">
+                <a:solidFill>
+                  <a:srgbClr val="66767A"/>
+                </a:solidFill>
+                <a:latin typeface="Aptos"/>
+              </a:rPr>
+              <a:t>Mention live deployment, API docs, 25 tests, known limits and the production roadmap.</a:t>
+            </a:r>
+          </a:p>
+        </p:txBody>
+      </p:sp>
+      <p:sp>
+        <p:nvSpPr>
+          <p:cNvPr id="26" name="TextBox 25"/>
+          <p:cNvSpPr txBox="1"/>
+          <p:nvPr/>
+        </p:nvSpPr>
+        <p:spPr>
+          <a:xfrm>
+            <a:off x="658368" y="5806440"/>
+            <a:ext cx="9875520" cy="256032"/>
+          </a:xfrm>
+          <a:prstGeom prst="rect">
+            <a:avLst/>
+          </a:prstGeom>
+          <a:noFill/>
+        </p:spPr>
+        <p:txBody>
+          <a:bodyPr wrap="square" lIns="36576" rIns="36576" tIns="36576" bIns="36576" anchor="t">
+            <a:spAutoFit/>
+          </a:bodyPr>
+          <a:lstStyle/>
+          <a:p>
+            <a:pPr algn="l"/>
+            <a:r>
+              <a:rPr sz="1300" b="1">
+                <a:solidFill>
+                  <a:srgbClr val="C48A38"/>
+                </a:solidFill>
+                <a:latin typeface="Aptos"/>
+              </a:rPr>
+              <a:t>Tip: do the upload before your interview starts so the completed record is already available to open.</a:t>
             </a:r>
           </a:p>
         </p:txBody>
@@ -9854,7 +11406,7 @@
                 </a:solidFill>
                 <a:latin typeface="Aptos"/>
               </a:rPr>
-              <a:t>WHAT CHANGES BEYOND EVALUATION</a:t>
+              <a:t>READY TO SUBMIT</a:t>
             </a:r>
           </a:p>
         </p:txBody>
@@ -9889,7 +11441,7 @@
                 </a:solidFill>
                 <a:latin typeface="Aptos"/>
               </a:rPr>
-              <a:t>Limitations and production plan</a:t>
+              <a:t>Deployment and submission links</a:t>
             </a:r>
           </a:p>
         </p:txBody>
@@ -9981,7 +11533,7 @@
         <p:spPr>
           <a:xfrm>
             <a:off x="640080" y="1572768"/>
-            <a:ext cx="10332720" cy="320040"/>
+            <a:ext cx="10607040" cy="320040"/>
           </a:xfrm>
           <a:prstGeom prst="rect">
             <a:avLst/>
@@ -10002,7 +11554,7 @@
                 </a:solidFill>
                 <a:latin typeface="Aptos"/>
               </a:rPr>
-              <a:t>The evaluation deployment is intentionally small; the seams for production hardening are explicit.</a:t>
+              <a:t>Use these live links in the internship submission form and during your presentation.</a:t>
             </a:r>
           </a:p>
         </p:txBody>
@@ -10015,8 +11567,8 @@
         </p:nvSpPr>
         <p:spPr>
           <a:xfrm>
-            <a:off x="640080" y="2148840"/>
-            <a:ext cx="5166360" cy="2423160"/>
+            <a:off x="640080" y="2084831"/>
+            <a:ext cx="5212080" cy="1143000"/>
           </a:xfrm>
           <a:prstGeom prst="roundRect">
             <a:avLst/>
@@ -10060,14 +11612,14 @@
         </p:nvSpPr>
         <p:spPr>
           <a:xfrm>
-            <a:off x="640080" y="2148840"/>
-            <a:ext cx="54864" cy="2423160"/>
+            <a:off x="640080" y="2084831"/>
+            <a:ext cx="54864" cy="1143000"/>
           </a:xfrm>
           <a:prstGeom prst="rect">
             <a:avLst/>
           </a:prstGeom>
           <a:solidFill>
-            <a:srgbClr val="A84232"/>
+            <a:srgbClr val="0F766E"/>
           </a:solidFill>
           <a:ln>
             <a:noFill/>
@@ -10103,8 +11655,8 @@
         </p:nvSpPr>
         <p:spPr>
           <a:xfrm>
-            <a:off x="822959" y="2313432"/>
-            <a:ext cx="4846320" cy="274320"/>
+            <a:off x="822959" y="2249424"/>
+            <a:ext cx="4892040" cy="274320"/>
           </a:xfrm>
           <a:prstGeom prst="rect">
             <a:avLst/>
@@ -10125,7 +11677,7 @@
                 </a:solidFill>
                 <a:latin typeface="Aptos"/>
               </a:rPr>
-              <a:t>Current limitations</a:t>
+              <a:t>Deployed Backend API base URL</a:t>
             </a:r>
           </a:p>
         </p:txBody>
@@ -10138,8 +11690,8 @@
         </p:nvSpPr>
         <p:spPr>
           <a:xfrm>
-            <a:off x="822959" y="2670048"/>
-            <a:ext cx="4846320" cy="1783080"/>
+            <a:off x="822959" y="2606039"/>
+            <a:ext cx="4892040" cy="502920"/>
           </a:xfrm>
           <a:prstGeom prst="rect">
             <a:avLst/>
@@ -10154,30 +11706,63 @@
           <a:p>
             <a:pPr algn="l"/>
             <a:r>
-              <a:rPr sz="1400" b="0">
+              <a:rPr sz="1100" b="0">
                 <a:solidFill>
                   <a:srgbClr val="66767A"/>
                 </a:solidFill>
                 <a:latin typeface="Aptos"/>
               </a:rPr>
-              <a:t>Render Free local SQLite storage is ephemeral.
-No authentication or rate limiting.
-Large dense documents may need chunked extraction.
-Model confidence is not independently calibrated.</a:t>
-            </a:r>
-          </a:p>
-        </p:txBody>
-      </p:sp>
-      <p:sp>
-        <p:nvSpPr>
-          <p:cNvPr id="11" name="Rounded Rectangle 10"/>
+              <a:t>https://document-intelligence-platform-kace.onrender.com/api/v1</a:t>
+            </a:r>
+          </a:p>
+        </p:txBody>
+      </p:sp>
+      <p:sp>
+        <p:nvSpPr>
+          <p:cNvPr id="11" name="TextBox 10"/>
+          <p:cNvSpPr txBox="1"/>
+          <p:nvPr/>
+        </p:nvSpPr>
+        <p:spPr>
+          <a:xfrm>
+            <a:off x="868680" y="2798064"/>
+            <a:ext cx="2011680" cy="201168"/>
+          </a:xfrm>
+          <a:prstGeom prst="rect">
+            <a:avLst/>
+          </a:prstGeom>
+          <a:noFill/>
+        </p:spPr>
+        <p:txBody>
+          <a:bodyPr wrap="square" lIns="36576" rIns="36576" tIns="36576" bIns="36576" anchor="t">
+            <a:spAutoFit/>
+          </a:bodyPr>
+          <a:lstStyle/>
+          <a:p>
+            <a:pPr algn="l"/>
+            <a:r>
+              <a:rPr sz="1100" b="1">
+                <a:solidFill>
+                  <a:srgbClr val="0F766E"/>
+                </a:solidFill>
+                <a:latin typeface="Aptos"/>
+                <a:hlinkClick r:id="rId2"/>
+              </a:rPr>
+              <a:t>Open API base URL</a:t>
+            </a:r>
+          </a:p>
+        </p:txBody>
+      </p:sp>
+      <p:sp>
+        <p:nvSpPr>
+          <p:cNvPr id="12" name="Rounded Rectangle 11"/>
           <p:cNvSpPr/>
           <p:nvPr/>
         </p:nvSpPr>
         <p:spPr>
           <a:xfrm>
-            <a:off x="6126480" y="2148840"/>
-            <a:ext cx="5394960" cy="2423160"/>
+            <a:off x="6144768" y="2084831"/>
+            <a:ext cx="5376672" cy="1143000"/>
           </a:xfrm>
           <a:prstGeom prst="roundRect">
             <a:avLst/>
@@ -10215,14 +11800,208 @@
       </p:sp>
       <p:sp>
         <p:nvSpPr>
-          <p:cNvPr id="12" name="Rectangle 11"/>
+          <p:cNvPr id="13" name="Rectangle 12"/>
           <p:cNvSpPr/>
           <p:nvPr/>
         </p:nvSpPr>
         <p:spPr>
           <a:xfrm>
-            <a:off x="6126480" y="2148840"/>
-            <a:ext cx="54864" cy="2423160"/>
+            <a:off x="6144768" y="2084831"/>
+            <a:ext cx="54864" cy="1143000"/>
+          </a:xfrm>
+          <a:prstGeom prst="rect">
+            <a:avLst/>
+          </a:prstGeom>
+          <a:solidFill>
+            <a:srgbClr val="C48A38"/>
+          </a:solidFill>
+          <a:ln>
+            <a:noFill/>
+          </a:ln>
+        </p:spPr>
+        <p:style>
+          <a:lnRef idx="1">
+            <a:schemeClr val="accent1"/>
+          </a:lnRef>
+          <a:fillRef idx="3">
+            <a:schemeClr val="accent1"/>
+          </a:fillRef>
+          <a:effectRef idx="2">
+            <a:schemeClr val="accent1"/>
+          </a:effectRef>
+          <a:fontRef idx="minor">
+            <a:schemeClr val="lt1"/>
+          </a:fontRef>
+        </p:style>
+        <p:txBody>
+          <a:bodyPr rtlCol="0" anchor="ctr"/>
+          <a:lstStyle/>
+          <a:p>
+            <a:pPr algn="ctr"/>
+          </a:p>
+        </p:txBody>
+      </p:sp>
+      <p:sp>
+        <p:nvSpPr>
+          <p:cNvPr id="14" name="TextBox 13"/>
+          <p:cNvSpPr txBox="1"/>
+          <p:nvPr/>
+        </p:nvSpPr>
+        <p:spPr>
+          <a:xfrm>
+            <a:off x="6327648" y="2249424"/>
+            <a:ext cx="5056632" cy="274320"/>
+          </a:xfrm>
+          <a:prstGeom prst="rect">
+            <a:avLst/>
+          </a:prstGeom>
+          <a:noFill/>
+        </p:spPr>
+        <p:txBody>
+          <a:bodyPr wrap="square" lIns="36576" rIns="36576" tIns="36576" bIns="36576" anchor="t">
+            <a:spAutoFit/>
+          </a:bodyPr>
+          <a:lstStyle/>
+          <a:p>
+            <a:pPr algn="l"/>
+            <a:r>
+              <a:rPr sz="1300" b="1">
+                <a:solidFill>
+                  <a:srgbClr val="102C32"/>
+                </a:solidFill>
+                <a:latin typeface="Aptos"/>
+              </a:rPr>
+              <a:t>Deployed Frontend URL</a:t>
+            </a:r>
+          </a:p>
+        </p:txBody>
+      </p:sp>
+      <p:sp>
+        <p:nvSpPr>
+          <p:cNvPr id="15" name="TextBox 14"/>
+          <p:cNvSpPr txBox="1"/>
+          <p:nvPr/>
+        </p:nvSpPr>
+        <p:spPr>
+          <a:xfrm>
+            <a:off x="6327648" y="2606039"/>
+            <a:ext cx="5056632" cy="502920"/>
+          </a:xfrm>
+          <a:prstGeom prst="rect">
+            <a:avLst/>
+          </a:prstGeom>
+          <a:noFill/>
+        </p:spPr>
+        <p:txBody>
+          <a:bodyPr wrap="square" lIns="36576" rIns="36576" tIns="36576" bIns="36576" anchor="t">
+            <a:spAutoFit/>
+          </a:bodyPr>
+          <a:lstStyle/>
+          <a:p>
+            <a:pPr algn="l"/>
+            <a:r>
+              <a:rPr sz="1100" b="0">
+                <a:solidFill>
+                  <a:srgbClr val="66767A"/>
+                </a:solidFill>
+                <a:latin typeface="Aptos"/>
+              </a:rPr>
+              <a:t>https://document-intelligence-platform-kace.onrender.com/</a:t>
+            </a:r>
+          </a:p>
+        </p:txBody>
+      </p:sp>
+      <p:sp>
+        <p:nvSpPr>
+          <p:cNvPr id="16" name="TextBox 15"/>
+          <p:cNvSpPr txBox="1"/>
+          <p:nvPr/>
+        </p:nvSpPr>
+        <p:spPr>
+          <a:xfrm>
+            <a:off x="6373368" y="2798064"/>
+            <a:ext cx="2011680" cy="201168"/>
+          </a:xfrm>
+          <a:prstGeom prst="rect">
+            <a:avLst/>
+          </a:prstGeom>
+          <a:noFill/>
+        </p:spPr>
+        <p:txBody>
+          <a:bodyPr wrap="square" lIns="36576" rIns="36576" tIns="36576" bIns="36576" anchor="t">
+            <a:spAutoFit/>
+          </a:bodyPr>
+          <a:lstStyle/>
+          <a:p>
+            <a:pPr algn="l"/>
+            <a:r>
+              <a:rPr sz="1100" b="1">
+                <a:solidFill>
+                  <a:srgbClr val="0F766E"/>
+                </a:solidFill>
+                <a:latin typeface="Aptos"/>
+                <a:hlinkClick r:id="rId3"/>
+              </a:rPr>
+              <a:t>Open live frontend</a:t>
+            </a:r>
+          </a:p>
+        </p:txBody>
+      </p:sp>
+      <p:sp>
+        <p:nvSpPr>
+          <p:cNvPr id="17" name="Rounded Rectangle 16"/>
+          <p:cNvSpPr/>
+          <p:nvPr/>
+        </p:nvSpPr>
+        <p:spPr>
+          <a:xfrm>
+            <a:off x="640080" y="3456432"/>
+            <a:ext cx="5212080" cy="1143000"/>
+          </a:xfrm>
+          <a:prstGeom prst="roundRect">
+            <a:avLst/>
+          </a:prstGeom>
+          <a:solidFill>
+            <a:srgbClr val="FFFFFF"/>
+          </a:solidFill>
+          <a:ln w="10160">
+            <a:solidFill>
+              <a:srgbClr val="D6E1DE"/>
+            </a:solidFill>
+          </a:ln>
+        </p:spPr>
+        <p:style>
+          <a:lnRef idx="1">
+            <a:schemeClr val="accent1"/>
+          </a:lnRef>
+          <a:fillRef idx="3">
+            <a:schemeClr val="accent1"/>
+          </a:fillRef>
+          <a:effectRef idx="2">
+            <a:schemeClr val="accent1"/>
+          </a:effectRef>
+          <a:fontRef idx="minor">
+            <a:schemeClr val="lt1"/>
+          </a:fontRef>
+        </p:style>
+        <p:txBody>
+          <a:bodyPr rtlCol="0" anchor="ctr"/>
+          <a:lstStyle/>
+          <a:p>
+            <a:pPr algn="ctr"/>
+          </a:p>
+        </p:txBody>
+      </p:sp>
+      <p:sp>
+        <p:nvSpPr>
+          <p:cNvPr id="18" name="Rectangle 17"/>
+          <p:cNvSpPr/>
+          <p:nvPr/>
+        </p:nvSpPr>
+        <p:spPr>
+          <a:xfrm>
+            <a:off x="640080" y="3456432"/>
+            <a:ext cx="54864" cy="1143000"/>
           </a:xfrm>
           <a:prstGeom prst="rect">
             <a:avLst/>
@@ -10258,14 +12037,14 @@
       </p:sp>
       <p:sp>
         <p:nvSpPr>
-          <p:cNvPr id="13" name="TextBox 12"/>
-          <p:cNvSpPr txBox="1"/>
-          <p:nvPr/>
-        </p:nvSpPr>
-        <p:spPr>
-          <a:xfrm>
-            <a:off x="6309360" y="2313432"/>
-            <a:ext cx="5074920" cy="274320"/>
+          <p:cNvPr id="19" name="TextBox 18"/>
+          <p:cNvSpPr txBox="1"/>
+          <p:nvPr/>
+        </p:nvSpPr>
+        <p:spPr>
+          <a:xfrm>
+            <a:off x="822959" y="3621024"/>
+            <a:ext cx="4892040" cy="274320"/>
           </a:xfrm>
           <a:prstGeom prst="rect">
             <a:avLst/>
@@ -10286,21 +12065,21 @@
                 </a:solidFill>
                 <a:latin typeface="Aptos"/>
               </a:rPr>
-              <a:t>Production changes</a:t>
-            </a:r>
-          </a:p>
-        </p:txBody>
-      </p:sp>
-      <p:sp>
-        <p:nvSpPr>
-          <p:cNvPr id="14" name="TextBox 13"/>
-          <p:cNvSpPr txBox="1"/>
-          <p:nvPr/>
-        </p:nvSpPr>
-        <p:spPr>
-          <a:xfrm>
-            <a:off x="6309360" y="2670048"/>
-            <a:ext cx="5074920" cy="1783080"/>
+              <a:t>Deployment platform used</a:t>
+            </a:r>
+          </a:p>
+        </p:txBody>
+      </p:sp>
+      <p:sp>
+        <p:nvSpPr>
+          <p:cNvPr id="20" name="TextBox 19"/>
+          <p:cNvSpPr txBox="1"/>
+          <p:nvPr/>
+        </p:nvSpPr>
+        <p:spPr>
+          <a:xfrm>
+            <a:off x="822959" y="3977639"/>
+            <a:ext cx="4892040" cy="502920"/>
           </a:xfrm>
           <a:prstGeom prst="rect">
             <a:avLst/>
@@ -10315,30 +12094,115 @@
           <a:p>
             <a:pPr algn="l"/>
             <a:r>
-              <a:rPr sz="1400" b="0">
+              <a:rPr sz="1300" b="0">
                 <a:solidFill>
                   <a:srgbClr val="66767A"/>
                 </a:solidFill>
                 <a:latin typeface="Aptos"/>
               </a:rPr>
-              <a:t>Managed Postgres and object storage.
-Durable worker queue and observability.
-Authentication, tenant isolation and quotas.
-Golden-document evaluations and reconciliation expansion.</a:t>
-            </a:r>
-          </a:p>
-        </p:txBody>
-      </p:sp>
-      <p:sp>
-        <p:nvSpPr>
-          <p:cNvPr id="15" name="TextBox 14"/>
-          <p:cNvSpPr txBox="1"/>
-          <p:nvPr/>
-        </p:nvSpPr>
-        <p:spPr>
-          <a:xfrm>
-            <a:off x="640080" y="5138928"/>
-            <a:ext cx="2377440" cy="256032"/>
+              <a:t>Render - Docker web service on the Free plan</a:t>
+            </a:r>
+          </a:p>
+        </p:txBody>
+      </p:sp>
+      <p:sp>
+        <p:nvSpPr>
+          <p:cNvPr id="21" name="Rounded Rectangle 20"/>
+          <p:cNvSpPr/>
+          <p:nvPr/>
+        </p:nvSpPr>
+        <p:spPr>
+          <a:xfrm>
+            <a:off x="6144768" y="3456432"/>
+            <a:ext cx="5376672" cy="1143000"/>
+          </a:xfrm>
+          <a:prstGeom prst="roundRect">
+            <a:avLst/>
+          </a:prstGeom>
+          <a:solidFill>
+            <a:srgbClr val="FFFFFF"/>
+          </a:solidFill>
+          <a:ln w="10160">
+            <a:solidFill>
+              <a:srgbClr val="D6E1DE"/>
+            </a:solidFill>
+          </a:ln>
+        </p:spPr>
+        <p:style>
+          <a:lnRef idx="1">
+            <a:schemeClr val="accent1"/>
+          </a:lnRef>
+          <a:fillRef idx="3">
+            <a:schemeClr val="accent1"/>
+          </a:fillRef>
+          <a:effectRef idx="2">
+            <a:schemeClr val="accent1"/>
+          </a:effectRef>
+          <a:fontRef idx="minor">
+            <a:schemeClr val="lt1"/>
+          </a:fontRef>
+        </p:style>
+        <p:txBody>
+          <a:bodyPr rtlCol="0" anchor="ctr"/>
+          <a:lstStyle/>
+          <a:p>
+            <a:pPr algn="ctr"/>
+          </a:p>
+        </p:txBody>
+      </p:sp>
+      <p:sp>
+        <p:nvSpPr>
+          <p:cNvPr id="22" name="Rectangle 21"/>
+          <p:cNvSpPr/>
+          <p:nvPr/>
+        </p:nvSpPr>
+        <p:spPr>
+          <a:xfrm>
+            <a:off x="6144768" y="3456432"/>
+            <a:ext cx="54864" cy="1143000"/>
+          </a:xfrm>
+          <a:prstGeom prst="rect">
+            <a:avLst/>
+          </a:prstGeom>
+          <a:solidFill>
+            <a:srgbClr val="C48A38"/>
+          </a:solidFill>
+          <a:ln>
+            <a:noFill/>
+          </a:ln>
+        </p:spPr>
+        <p:style>
+          <a:lnRef idx="1">
+            <a:schemeClr val="accent1"/>
+          </a:lnRef>
+          <a:fillRef idx="3">
+            <a:schemeClr val="accent1"/>
+          </a:fillRef>
+          <a:effectRef idx="2">
+            <a:schemeClr val="accent1"/>
+          </a:effectRef>
+          <a:fontRef idx="minor">
+            <a:schemeClr val="lt1"/>
+          </a:fontRef>
+        </p:style>
+        <p:txBody>
+          <a:bodyPr rtlCol="0" anchor="ctr"/>
+          <a:lstStyle/>
+          <a:p>
+            <a:pPr algn="ctr"/>
+          </a:p>
+        </p:txBody>
+      </p:sp>
+      <p:sp>
+        <p:nvSpPr>
+          <p:cNvPr id="23" name="TextBox 22"/>
+          <p:cNvSpPr txBox="1"/>
+          <p:nvPr/>
+        </p:nvSpPr>
+        <p:spPr>
+          <a:xfrm>
+            <a:off x="6327648" y="3621024"/>
+            <a:ext cx="5056632" cy="274320"/>
           </a:xfrm>
           <a:prstGeom prst="rect">
             <a:avLst/>
@@ -10353,27 +12217,133 @@
           <a:p>
             <a:pPr algn="l"/>
             <a:r>
+              <a:rPr sz="1300" b="1">
+                <a:solidFill>
+                  <a:srgbClr val="102C32"/>
+                </a:solidFill>
+                <a:latin typeface="Aptos"/>
+              </a:rPr>
+              <a:t>Public GitHub repository</a:t>
+            </a:r>
+          </a:p>
+        </p:txBody>
+      </p:sp>
+      <p:sp>
+        <p:nvSpPr>
+          <p:cNvPr id="24" name="TextBox 23"/>
+          <p:cNvSpPr txBox="1"/>
+          <p:nvPr/>
+        </p:nvSpPr>
+        <p:spPr>
+          <a:xfrm>
+            <a:off x="6327648" y="3977639"/>
+            <a:ext cx="5056632" cy="502920"/>
+          </a:xfrm>
+          <a:prstGeom prst="rect">
+            <a:avLst/>
+          </a:prstGeom>
+          <a:noFill/>
+        </p:spPr>
+        <p:txBody>
+          <a:bodyPr wrap="square" lIns="36576" rIns="36576" tIns="36576" bIns="36576" anchor="t">
+            <a:spAutoFit/>
+          </a:bodyPr>
+          <a:lstStyle/>
+          <a:p>
+            <a:pPr algn="l"/>
+            <a:r>
+              <a:rPr sz="1200" b="0">
+                <a:solidFill>
+                  <a:srgbClr val="66767A"/>
+                </a:solidFill>
+                <a:latin typeface="Aptos"/>
+              </a:rPr>
+              <a:t>github.com/SakthiPriyaR/document-intelligence-platform</a:t>
+            </a:r>
+          </a:p>
+        </p:txBody>
+      </p:sp>
+      <p:sp>
+        <p:nvSpPr>
+          <p:cNvPr id="25" name="TextBox 24"/>
+          <p:cNvSpPr txBox="1"/>
+          <p:nvPr/>
+        </p:nvSpPr>
+        <p:spPr>
+          <a:xfrm>
+            <a:off x="6373368" y="4169663"/>
+            <a:ext cx="2560320" cy="201168"/>
+          </a:xfrm>
+          <a:prstGeom prst="rect">
+            <a:avLst/>
+          </a:prstGeom>
+          <a:noFill/>
+        </p:spPr>
+        <p:txBody>
+          <a:bodyPr wrap="square" lIns="36576" rIns="36576" tIns="36576" bIns="36576" anchor="t">
+            <a:spAutoFit/>
+          </a:bodyPr>
+          <a:lstStyle/>
+          <a:p>
+            <a:pPr algn="l"/>
+            <a:r>
+              <a:rPr sz="1100" b="1">
+                <a:solidFill>
+                  <a:srgbClr val="0F766E"/>
+                </a:solidFill>
+                <a:latin typeface="Aptos"/>
+                <a:hlinkClick r:id="rId4"/>
+              </a:rPr>
+              <a:t>Open public repository</a:t>
+            </a:r>
+          </a:p>
+        </p:txBody>
+      </p:sp>
+      <p:sp>
+        <p:nvSpPr>
+          <p:cNvPr id="26" name="TextBox 25"/>
+          <p:cNvSpPr txBox="1"/>
+          <p:nvPr/>
+        </p:nvSpPr>
+        <p:spPr>
+          <a:xfrm>
+            <a:off x="640080" y="5148072"/>
+            <a:ext cx="1371600" cy="237744"/>
+          </a:xfrm>
+          <a:prstGeom prst="rect">
+            <a:avLst/>
+          </a:prstGeom>
+          <a:noFill/>
+        </p:spPr>
+        <p:txBody>
+          <a:bodyPr wrap="square" lIns="36576" rIns="36576" tIns="36576" bIns="36576" anchor="t">
+            <a:spAutoFit/>
+          </a:bodyPr>
+          <a:lstStyle/>
+          <a:p>
+            <a:pPr algn="l"/>
+            <a:r>
               <a:rPr sz="1400" b="1">
                 <a:solidFill>
-                  <a:srgbClr val="C48A38"/>
-                </a:solidFill>
-                <a:latin typeface="Aptos"/>
-              </a:rPr>
-              <a:t>Important distinction</a:t>
-            </a:r>
-          </a:p>
-        </p:txBody>
-      </p:sp>
-      <p:sp>
-        <p:nvSpPr>
-          <p:cNvPr id="16" name="TextBox 15"/>
-          <p:cNvSpPr txBox="1"/>
-          <p:nvPr/>
-        </p:nvSpPr>
-        <p:spPr>
-          <a:xfrm>
-            <a:off x="658368" y="5486400"/>
-            <a:ext cx="10332720" cy="320040"/>
+                  <a:srgbClr val="0F766E"/>
+                </a:solidFill>
+                <a:latin typeface="Aptos"/>
+              </a:rPr>
+              <a:t>PPT sharing</a:t>
+            </a:r>
+          </a:p>
+        </p:txBody>
+      </p:sp>
+      <p:sp>
+        <p:nvSpPr>
+          <p:cNvPr id="27" name="TextBox 26"/>
+          <p:cNvSpPr txBox="1"/>
+          <p:nvPr/>
+        </p:nvSpPr>
+        <p:spPr>
+          <a:xfrm>
+            <a:off x="658368" y="5504688"/>
+            <a:ext cx="4206240" cy="237744"/>
           </a:xfrm>
           <a:prstGeom prst="rect">
             <a:avLst/>
@@ -10388,13 +12358,49 @@
           <a:p>
             <a:pPr algn="l"/>
             <a:r>
-              <a:rPr sz="1600" b="0">
+              <a:rPr sz="1200" b="1">
+                <a:solidFill>
+                  <a:srgbClr val="0F766E"/>
+                </a:solidFill>
+                <a:latin typeface="Aptos"/>
+                <a:hlinkClick r:id="rId5"/>
+              </a:rPr>
+              <a:t>Download the version-controlled PPTX from GitHub</a:t>
+            </a:r>
+          </a:p>
+        </p:txBody>
+      </p:sp>
+      <p:sp>
+        <p:nvSpPr>
+          <p:cNvPr id="28" name="TextBox 27"/>
+          <p:cNvSpPr txBox="1"/>
+          <p:nvPr/>
+        </p:nvSpPr>
+        <p:spPr>
+          <a:xfrm>
+            <a:off x="5102352" y="5413248"/>
+            <a:ext cx="6080760" cy="502920"/>
+          </a:xfrm>
+          <a:prstGeom prst="rect">
+            <a:avLst/>
+          </a:prstGeom>
+          <a:noFill/>
+        </p:spPr>
+        <p:txBody>
+          <a:bodyPr wrap="square" lIns="36576" rIns="36576" tIns="36576" bIns="36576" anchor="t">
+            <a:spAutoFit/>
+          </a:bodyPr>
+          <a:lstStyle/>
+          <a:p>
+            <a:pPr algn="l"/>
+            <a:r>
+              <a:rPr sz="1300" b="0">
                 <a:solidFill>
                   <a:srgbClr val="102C32"/>
                 </a:solidFill>
                 <a:latin typeface="Aptos"/>
               </a:rPr>
-              <a:t>The current live extraction flow works; durable history requires a persistent database plan.</a:t>
+              <a:t>Google Drive submission: upload this PPTX to your Drive, set General access to 'Anyone with the link - Viewer', then paste that share URL into the form.</a:t>
             </a:r>
           </a:p>
         </p:txBody>

</xml_diff>

<commit_message>
Use health endpoint and remove talk track
</commit_message>
<xml_diff>
--- a/docs/solution_presentation.pptx
+++ b/docs/solution_presentation.pptx
@@ -11677,7 +11677,7 @@
                 </a:solidFill>
                 <a:latin typeface="Aptos"/>
               </a:rPr>
-              <a:t>Deployed Backend API base URL</a:t>
+              <a:t>Deployed Backend API (health)</a:t>
             </a:r>
           </a:p>
         </p:txBody>
@@ -11706,13 +11706,13 @@
           <a:p>
             <a:pPr algn="l"/>
             <a:r>
-              <a:rPr sz="1100" b="0">
+              <a:rPr sz="1000" b="0">
                 <a:solidFill>
                   <a:srgbClr val="66767A"/>
                 </a:solidFill>
                 <a:latin typeface="Aptos"/>
               </a:rPr>
-              <a:t>https://document-intelligence-platform-kace.onrender.com/api/v1</a:t>
+              <a:t>https://document-intelligence-platform-kace.onrender.com/api/v1/health</a:t>
             </a:r>
           </a:p>
         </p:txBody>
@@ -11726,7 +11726,7 @@
         <p:spPr>
           <a:xfrm>
             <a:off x="868680" y="2798064"/>
-            <a:ext cx="2011680" cy="201168"/>
+            <a:ext cx="2560320" cy="201168"/>
           </a:xfrm>
           <a:prstGeom prst="rect">
             <a:avLst/>
@@ -11748,7 +11748,7 @@
                 <a:latin typeface="Aptos"/>
                 <a:hlinkClick r:id="rId2"/>
               </a:rPr>
-              <a:t>Open API base URL</a:t>
+              <a:t>Open working API endpoint</a:t>
             </a:r>
           </a:p>
         </p:txBody>

</xml_diff>

<commit_message>
Polish health response and documentation
</commit_message>
<xml_diff>
--- a/docs/solution_presentation.pptx
+++ b/docs/solution_presentation.pptx
@@ -4096,7 +4096,7 @@
                 </a:solidFill>
                 <a:latin typeface="Aptos"/>
               </a:rPr>
-              <a:t>TRANSPARENT ENGINEERING</a:t>
+              <a:t>ENGINEERING DISCIPLINE</a:t>
             </a:r>
           </a:p>
         </p:txBody>
@@ -4131,7 +4131,7 @@
                 </a:solidFill>
                 <a:latin typeface="Aptos"/>
               </a:rPr>
-              <a:t>AI usage and submission deliverables</a:t>
+              <a:t>Delivery quality and submission materials</a:t>
             </a:r>
           </a:p>
         </p:txBody>
@@ -4332,7 +4332,7 @@
                 </a:solidFill>
                 <a:latin typeface="Aptos"/>
               </a:rPr>
-              <a:t>AI usage declaration</a:t>
+              <a:t>Delivery quality</a:t>
             </a:r>
           </a:p>
         </p:txBody>
@@ -4367,8 +4367,8 @@
                 </a:solidFill>
                 <a:latin typeface="Aptos"/>
               </a:rPr>
-              <a:t>An AI coding assistant supported the initial scaffold, service boundaries, validation engine, frontend, tests, documentation and this presentation.
-The source was reviewed and locally test-verified. Gemini is used at runtime only for evidence-backed field extraction after explicit configuration.</a:t>
+              <a:t>Modular service boundaries, controlled failures, environment-based configuration and automated tests keep the system maintainable.
+Gemini is used at runtime only for evidence-backed field extraction after explicit configuration.</a:t>
             </a:r>
           </a:p>
         </p:txBody>

</xml_diff>